<commit_message>
Cut README to one page, split findings out, add repo link to the deck
The brief asks for a one-page README. It had grown to 373 lines / ~2,900
words, so the investigation material moves to FINDINGS.md and README.md
keeps what the brief actually asks of it: approach, tools, assumptions,
setup, and one worked example of input and output. Now 155 lines.

Slide 5 of the deck specifies "demo or repository links" and carried
neither. It now shows the GitHub URL and points at both documents.

Co-Authored-By: Claude Opus 5 <noreply@anthropic.com>
</commit_message>
<xml_diff>
--- a/Clinical_Document_Intelligence_Hub_deck.pptx
+++ b/Clinical_Document_Intelligence_Hub_deck.pptx
@@ -10575,14 +10575,58 @@
       </p:sp>
       <p:sp>
         <p:nvSpPr>
-          <p:cNvPr id="17" name="TextBox 16"/>
+          <p:cNvPr id="17" name="Rectangle 16"/>
+          <p:cNvSpPr/>
+          <p:nvPr/>
+        </p:nvSpPr>
+        <p:spPr>
+          <a:xfrm>
+            <a:off x="566928" y="6327648"/>
+            <a:ext cx="11057839" cy="9525"/>
+          </a:xfrm>
+          <a:prstGeom prst="rect">
+            <a:avLst/>
+          </a:prstGeom>
+          <a:solidFill>
+            <a:srgbClr val="C9D4DA"/>
+          </a:solidFill>
+          <a:ln>
+            <a:noFill/>
+          </a:ln>
+          <a:effectLst/>
+        </p:spPr>
+        <p:style>
+          <a:lnRef idx="1">
+            <a:schemeClr val="accent1"/>
+          </a:lnRef>
+          <a:fillRef idx="3">
+            <a:schemeClr val="accent1"/>
+          </a:fillRef>
+          <a:effectRef idx="2">
+            <a:schemeClr val="accent1"/>
+          </a:effectRef>
+          <a:fontRef idx="minor">
+            <a:schemeClr val="lt1"/>
+          </a:fontRef>
+        </p:style>
+        <p:txBody>
+          <a:bodyPr rtlCol="0" anchor="ctr"/>
+          <a:lstStyle/>
+          <a:p>
+            <a:pPr algn="ctr"/>
+          </a:p>
+        </p:txBody>
+      </p:sp>
+      <p:sp>
+        <p:nvSpPr>
+          <p:cNvPr id="18" name="TextBox 17"/>
           <p:cNvSpPr txBox="1"/>
           <p:nvPr/>
         </p:nvSpPr>
         <p:spPr>
           <a:xfrm>
-            <a:off x="566928" y="6382512"/>
-            <a:ext cx="11057839" cy="274320"/>
+            <a:off x="566928" y="6419088"/>
+            <a:ext cx="11064240" cy="274320"/>
           </a:xfrm>
           <a:prstGeom prst="rect">
             <a:avLst/>
@@ -10604,13 +10648,31 @@
               </a:spcAft>
             </a:pPr>
             <a:r>
+              <a:rPr sz="1000" b="1" i="0">
+                <a:solidFill>
+                  <a:srgbClr val="0F4C5C"/>
+                </a:solidFill>
+                <a:latin typeface="Calibri"/>
+              </a:rPr>
+              <a:t>Repository   </a:t>
+            </a:r>
+            <a:r>
+              <a:rPr sz="1050" b="1" i="0">
+                <a:solidFill>
+                  <a:srgbClr val="16232E"/>
+                </a:solidFill>
+                <a:latin typeface="Consolas"/>
+              </a:rPr>
+              <a:t>github.com/anushkavb4/clinical-document-intelligence-hub</a:t>
+            </a:r>
+            <a:r>
               <a:rPr sz="950" b="0" i="0">
                 <a:solidFill>
                   <a:srgbClr val="5A6B78"/>
                 </a:solidFill>
                 <a:latin typeface="Calibri"/>
               </a:rPr>
-              <a:t>Repository: README.md documents setup, assumptions, one worked example and the measured limitations.  ·  Synthetic data only.</a:t>
+              <a:t>      README.md — setup and worked example   ·   FINDINGS.md — measured findings   ·   Synthetic data only.</a:t>
             </a:r>
           </a:p>
         </p:txBody>

</xml_diff>

<commit_message>
Put a UI screenshot on slide 3
The brief specifies "screenshots or concise code snippets" for slide 3; it
carried code only. It now shows the summary card beside the extraction call,
so the deck evidences both the output and the mechanism.

Screenshot committed to docs/ as a supporting asset, cropped to drop the
browser chrome and the line the viewport clipped mid-sentence. The $ref note
moves into the code caption to make room.

Co-Authored-By: Claude Opus 5 <noreply@anthropic.com>
</commit_message>
<xml_diff>
--- a/Clinical_Document_Intelligence_Hub_deck.pptx
+++ b/Clinical_Document_Intelligence_Hub_deck.pptx
@@ -5792,7 +5792,7 @@
                 </a:solidFill>
                 <a:latin typeface="Calibri"/>
               </a:rPr>
-              <a:t>Four decisions, and the numbers they produced</a:t>
+              <a:t>The card a reviewer sees, and the call that produces it</a:t>
             </a:r>
           </a:p>
         </p:txBody>
@@ -5850,7 +5850,7 @@
         <p:spPr>
           <a:xfrm>
             <a:off x="566928" y="1536192"/>
-            <a:ext cx="5532120" cy="2523744"/>
+            <a:ext cx="5715000" cy="2681699"/>
           </a:xfrm>
           <a:prstGeom prst="roundRect">
             <a:avLst>
@@ -5889,48 +5889,30 @@
           </a:p>
         </p:txBody>
       </p:sp>
-      <p:sp>
-        <p:nvSpPr>
-          <p:cNvPr id="8" name="TextBox 7"/>
-          <p:cNvSpPr txBox="1"/>
+      <p:pic>
+        <p:nvPicPr>
+          <p:cNvPr id="8" name="Picture 7" descr="screenshot_summary_card.png"/>
+          <p:cNvPicPr>
+            <a:picLocks noChangeAspect="1"/>
+          </p:cNvPicPr>
           <p:nvPr/>
-        </p:nvSpPr>
-        <p:spPr>
-          <a:xfrm>
-            <a:off x="768096" y="1664208"/>
-            <a:ext cx="5129784" cy="219456"/>
+        </p:nvPicPr>
+        <p:blipFill>
+          <a:blip r:embed="rId2"/>
+          <a:stretch>
+            <a:fillRect/>
+          </a:stretch>
+        </p:blipFill>
+        <p:spPr>
+          <a:xfrm>
+            <a:off x="566928" y="1536192"/>
+            <a:ext cx="5715000" cy="2681699"/>
           </a:xfrm>
           <a:prstGeom prst="rect">
             <a:avLst/>
           </a:prstGeom>
-          <a:noFill/>
-        </p:spPr>
-        <p:txBody>
-          <a:bodyPr wrap="square" anchor="t" lIns="0" rIns="0" tIns="0" bIns="0">
-            <a:spAutoFit/>
-          </a:bodyPr>
-          <a:lstStyle/>
-          <a:p>
-            <a:pPr algn="l">
-              <a:spcBef>
-                <a:spcPts val="0"/>
-              </a:spcBef>
-              <a:spcAft>
-                <a:spcPts val="600"/>
-              </a:spcAft>
-            </a:pPr>
-            <a:r>
-              <a:rPr sz="1000" b="1" i="0">
-                <a:solidFill>
-                  <a:srgbClr val="7F9DA8"/>
-                </a:solidFill>
-                <a:latin typeface="Calibri"/>
-              </a:rPr>
-              <a:t>ONE CALL — THE API ENFORCES THE SCHEMA</a:t>
-            </a:r>
-          </a:p>
-        </p:txBody>
-      </p:sp>
+        </p:spPr>
+      </p:pic>
       <p:sp>
         <p:nvSpPr>
           <p:cNvPr id="9" name="TextBox 8"/>
@@ -5939,273 +5921,8 @@
         </p:nvSpPr>
         <p:spPr>
           <a:xfrm>
-            <a:off x="768096" y="1920240"/>
-            <a:ext cx="5129784" cy="2029968"/>
-          </a:xfrm>
-          <a:prstGeom prst="rect">
-            <a:avLst/>
-          </a:prstGeom>
-          <a:noFill/>
-        </p:spPr>
-        <p:txBody>
-          <a:bodyPr wrap="square" anchor="t" lIns="0" rIns="0" tIns="0" bIns="0">
-            <a:spAutoFit/>
-          </a:bodyPr>
-          <a:lstStyle/>
-          <a:p>
-            <a:pPr algn="l">
-              <a:lnSpc>
-                <a:spcPct val="100000"/>
-              </a:lnSpc>
-              <a:spcBef>
-                <a:spcPts val="0"/>
-              </a:spcBef>
-              <a:spcAft>
-                <a:spcPts val="150"/>
-              </a:spcAft>
-            </a:pPr>
-            <a:r>
-              <a:rPr sz="1050" b="0" i="0">
-                <a:solidFill>
-                  <a:srgbClr val="E4EDF2"/>
-                </a:solidFill>
-                <a:latin typeface="Consolas"/>
-              </a:rPr>
-              <a:t>interaction = client.interactions.create(</a:t>
-            </a:r>
-          </a:p>
-          <a:p>
-            <a:pPr>
-              <a:lnSpc>
-                <a:spcPct val="100000"/>
-              </a:lnSpc>
-              <a:spcBef>
-                <a:spcPts val="0"/>
-              </a:spcBef>
-              <a:spcAft>
-                <a:spcPts val="150"/>
-              </a:spcAft>
-            </a:pPr>
-            <a:r>
-              <a:rPr sz="1050" b="0" i="0">
-                <a:solidFill>
-                  <a:srgbClr val="E4EDF2"/>
-                </a:solidFill>
-                <a:latin typeface="Consolas"/>
-              </a:rPr>
-              <a:t>    model=model,</a:t>
-            </a:r>
-          </a:p>
-          <a:p>
-            <a:pPr>
-              <a:lnSpc>
-                <a:spcPct val="100000"/>
-              </a:lnSpc>
-              <a:spcBef>
-                <a:spcPts val="0"/>
-              </a:spcBef>
-              <a:spcAft>
-                <a:spcPts val="150"/>
-              </a:spcAft>
-            </a:pPr>
-            <a:r>
-              <a:rPr sz="1050" b="0" i="0">
-                <a:solidFill>
-                  <a:srgbClr val="E4EDF2"/>
-                </a:solidFill>
-                <a:latin typeface="Consolas"/>
-              </a:rPr>
-              <a:t>    system_instruction=SYSTEM_PROMPT,</a:t>
-            </a:r>
-          </a:p>
-          <a:p>
-            <a:pPr>
-              <a:lnSpc>
-                <a:spcPct val="100000"/>
-              </a:lnSpc>
-              <a:spcBef>
-                <a:spcPts val="0"/>
-              </a:spcBef>
-              <a:spcAft>
-                <a:spcPts val="150"/>
-              </a:spcAft>
-            </a:pPr>
-            <a:r>
-              <a:rPr sz="1050" b="0" i="0">
-                <a:solidFill>
-                  <a:srgbClr val="E4EDF2"/>
-                </a:solidFill>
-                <a:latin typeface="Consolas"/>
-              </a:rPr>
-              <a:t>    input=_input_blocks(document),</a:t>
-            </a:r>
-          </a:p>
-          <a:p>
-            <a:pPr>
-              <a:lnSpc>
-                <a:spcPct val="100000"/>
-              </a:lnSpc>
-              <a:spcBef>
-                <a:spcPts val="0"/>
-              </a:spcBef>
-              <a:spcAft>
-                <a:spcPts val="150"/>
-              </a:spcAft>
-            </a:pPr>
-            <a:r>
-              <a:rPr sz="1050" b="0" i="0">
-                <a:solidFill>
-                  <a:srgbClr val="E4EDF2"/>
-                </a:solidFill>
-                <a:latin typeface="Consolas"/>
-              </a:rPr>
-              <a:t>    response_format={</a:t>
-            </a:r>
-          </a:p>
-          <a:p>
-            <a:pPr>
-              <a:lnSpc>
-                <a:spcPct val="100000"/>
-              </a:lnSpc>
-              <a:spcBef>
-                <a:spcPts val="0"/>
-              </a:spcBef>
-              <a:spcAft>
-                <a:spcPts val="150"/>
-              </a:spcAft>
-            </a:pPr>
-            <a:r>
-              <a:rPr sz="1050" b="0" i="0">
-                <a:solidFill>
-                  <a:srgbClr val="B8E0A0"/>
-                </a:solidFill>
-                <a:latin typeface="Consolas"/>
-              </a:rPr>
-              <a:t>        "type": "text",</a:t>
-            </a:r>
-          </a:p>
-          <a:p>
-            <a:pPr>
-              <a:lnSpc>
-                <a:spcPct val="100000"/>
-              </a:lnSpc>
-              <a:spcBef>
-                <a:spcPts val="0"/>
-              </a:spcBef>
-              <a:spcAft>
-                <a:spcPts val="150"/>
-              </a:spcAft>
-            </a:pPr>
-            <a:r>
-              <a:rPr sz="1050" b="0" i="0">
-                <a:solidFill>
-                  <a:srgbClr val="B8E0A0"/>
-                </a:solidFill>
-                <a:latin typeface="Consolas"/>
-              </a:rPr>
-              <a:t>        "mime_type": "application/json",</a:t>
-            </a:r>
-          </a:p>
-          <a:p>
-            <a:pPr>
-              <a:lnSpc>
-                <a:spcPct val="100000"/>
-              </a:lnSpc>
-              <a:spcBef>
-                <a:spcPts val="0"/>
-              </a:spcBef>
-              <a:spcAft>
-                <a:spcPts val="150"/>
-              </a:spcAft>
-            </a:pPr>
-            <a:r>
-              <a:rPr sz="1050" b="0" i="0">
-                <a:solidFill>
-                  <a:srgbClr val="B8E0A0"/>
-                </a:solidFill>
-                <a:latin typeface="Consolas"/>
-              </a:rPr>
-              <a:t>        "schema": response_schema(),</a:t>
-            </a:r>
-          </a:p>
-          <a:p>
-            <a:pPr>
-              <a:lnSpc>
-                <a:spcPct val="100000"/>
-              </a:lnSpc>
-              <a:spcBef>
-                <a:spcPts val="0"/>
-              </a:spcBef>
-              <a:spcAft>
-                <a:spcPts val="150"/>
-              </a:spcAft>
-            </a:pPr>
-            <a:r>
-              <a:rPr sz="1050" b="0" i="0">
-                <a:solidFill>
-                  <a:srgbClr val="E4EDF2"/>
-                </a:solidFill>
-                <a:latin typeface="Consolas"/>
-              </a:rPr>
-              <a:t>    },</a:t>
-            </a:r>
-          </a:p>
-          <a:p>
-            <a:pPr>
-              <a:lnSpc>
-                <a:spcPct val="100000"/>
-              </a:lnSpc>
-              <a:spcBef>
-                <a:spcPts val="0"/>
-              </a:spcBef>
-              <a:spcAft>
-                <a:spcPts val="150"/>
-              </a:spcAft>
-            </a:pPr>
-            <a:r>
-              <a:rPr sz="1050" b="0" i="0">
-                <a:solidFill>
-                  <a:srgbClr val="6B8794"/>
-                </a:solidFill>
-                <a:latin typeface="Consolas"/>
-              </a:rPr>
-              <a:t>    store=False,   # no clinical text retained</a:t>
-            </a:r>
-          </a:p>
-          <a:p>
-            <a:pPr>
-              <a:lnSpc>
-                <a:spcPct val="100000"/>
-              </a:lnSpc>
-              <a:spcBef>
-                <a:spcPts val="0"/>
-              </a:spcBef>
-              <a:spcAft>
-                <a:spcPts val="150"/>
-              </a:spcAft>
-            </a:pPr>
-            <a:r>
-              <a:rPr sz="1050" b="0" i="0">
-                <a:solidFill>
-                  <a:srgbClr val="E4EDF2"/>
-                </a:solidFill>
-                <a:latin typeface="Consolas"/>
-              </a:rPr>
-              <a:t>)</a:t>
-            </a:r>
-          </a:p>
-        </p:txBody>
-      </p:sp>
-      <p:sp>
-        <p:nvSpPr>
-          <p:cNvPr id="10" name="TextBox 9"/>
-          <p:cNvSpPr txBox="1"/>
-          <p:nvPr/>
-        </p:nvSpPr>
-        <p:spPr>
-          <a:xfrm>
-            <a:off x="566928" y="4169663"/>
-            <a:ext cx="5532120" cy="603504"/>
+            <a:off x="566928" y="4327619"/>
+            <a:ext cx="5715000" cy="548640"/>
           </a:xfrm>
           <a:prstGeom prst="rect">
             <a:avLst/>
@@ -6230,27 +5947,54 @@
               </a:spcAft>
             </a:pPr>
             <a:r>
+              <a:rPr sz="1100" b="1" i="0">
+                <a:solidFill>
+                  <a:srgbClr val="16232E"/>
+                </a:solidFill>
+                <a:latin typeface="Calibri"/>
+              </a:rPr>
+              <a:t>Risk band, then the fields it rests on. </a:t>
+            </a:r>
+            <a:r>
               <a:rPr sz="1100" b="0" i="0">
                 <a:solidFill>
                   <a:srgbClr val="5A6B78"/>
                 </a:solidFill>
                 <a:latin typeface="Calibri"/>
               </a:rPr>
-              <a:t>No JSON parsing, no repair loop, no prose-to-struct step that can drift. The response is constrained on the way out and re-validated by Pydantic on the way in — a malformed record raises rather than reaching the UI.</a:t>
-            </a:r>
-          </a:p>
-        </p:txBody>
-      </p:sp>
-      <p:sp>
-        <p:nvSpPr>
-          <p:cNvPr id="11" name="Rounded Rectangle 10"/>
+              <a:t>Each value carries a confidence marker and an expandable </a:t>
+            </a:r>
+            <a:r>
+              <a:rPr sz="1100" b="0" i="0">
+                <a:solidFill>
+                  <a:srgbClr val="16232E"/>
+                </a:solidFill>
+                <a:latin typeface="Consolas"/>
+              </a:rPr>
+              <a:t>source</a:t>
+            </a:r>
+            <a:r>
+              <a:rPr sz="1100" b="0" i="0">
+                <a:solidFill>
+                  <a:srgbClr val="5A6B78"/>
+                </a:solidFill>
+                <a:latin typeface="Calibri"/>
+              </a:rPr>
+              <a:t> holding the verbatim quote it came from.</a:t>
+            </a:r>
+          </a:p>
+        </p:txBody>
+      </p:sp>
+      <p:sp>
+        <p:nvSpPr>
+          <p:cNvPr id="10" name="Rounded Rectangle 9"/>
           <p:cNvSpPr/>
           <p:nvPr/>
         </p:nvSpPr>
         <p:spPr>
           <a:xfrm>
-            <a:off x="6355080" y="1536192"/>
-            <a:ext cx="5276088" cy="2523744"/>
+            <a:off x="6601968" y="1536192"/>
+            <a:ext cx="5029200" cy="2681699"/>
           </a:xfrm>
           <a:prstGeom prst="roundRect">
             <a:avLst>
@@ -6291,14 +6035,14 @@
       </p:sp>
       <p:sp>
         <p:nvSpPr>
-          <p:cNvPr id="12" name="TextBox 11"/>
+          <p:cNvPr id="11" name="TextBox 10"/>
           <p:cNvSpPr txBox="1"/>
           <p:nvPr/>
         </p:nvSpPr>
         <p:spPr>
           <a:xfrm>
-            <a:off x="6556248" y="1664208"/>
-            <a:ext cx="4873752" cy="219456"/>
+            <a:off x="6803136" y="1664208"/>
+            <a:ext cx="4626864" cy="219456"/>
           </a:xfrm>
           <a:prstGeom prst="rect">
             <a:avLst/>
@@ -6326,21 +6070,21 @@
                 </a:solidFill>
                 <a:latin typeface="Calibri"/>
               </a:rPr>
-              <a:t>THE PROVIDER GOTCHA WORTH KNOWING</a:t>
-            </a:r>
-          </a:p>
-        </p:txBody>
-      </p:sp>
-      <p:sp>
-        <p:nvSpPr>
-          <p:cNvPr id="13" name="TextBox 12"/>
+              <a:t>ONE CALL — THE API ENFORCES THE SCHEMA</a:t>
+            </a:r>
+          </a:p>
+        </p:txBody>
+      </p:sp>
+      <p:sp>
+        <p:nvSpPr>
+          <p:cNvPr id="12" name="TextBox 11"/>
           <p:cNvSpPr txBox="1"/>
           <p:nvPr/>
         </p:nvSpPr>
         <p:spPr>
           <a:xfrm>
-            <a:off x="6556248" y="1920240"/>
-            <a:ext cx="4873752" cy="2029968"/>
+            <a:off x="6803136" y="1920240"/>
+            <a:ext cx="4626864" cy="2187923"/>
           </a:xfrm>
           <a:prstGeom prst="rect">
             <a:avLst/>
@@ -6367,11 +6111,11 @@
             <a:r>
               <a:rPr sz="1050" b="0" i="0">
                 <a:solidFill>
-                  <a:srgbClr val="6B8794"/>
+                  <a:srgbClr val="E4EDF2"/>
                 </a:solidFill>
                 <a:latin typeface="Consolas"/>
               </a:rPr>
-              <a:t># Pydantic hoists nested models into $defs and</a:t>
+              <a:t>interaction = client.interactions.create(</a:t>
             </a:r>
           </a:p>
           <a:p>
@@ -6389,11 +6133,11 @@
             <a:r>
               <a:rPr sz="1050" b="0" i="0">
                 <a:solidFill>
-                  <a:srgbClr val="6B8794"/>
+                  <a:srgbClr val="E4EDF2"/>
                 </a:solidFill>
                 <a:latin typeface="Consolas"/>
               </a:rPr>
-              <a:t># points at them with $ref. Gemini documents no</a:t>
+              <a:t>    model=model,</a:t>
             </a:r>
           </a:p>
           <a:p>
@@ -6411,11 +6155,11 @@
             <a:r>
               <a:rPr sz="1050" b="0" i="0">
                 <a:solidFill>
-                  <a:srgbClr val="6B8794"/>
+                  <a:srgbClr val="E4EDF2"/>
                 </a:solidFill>
                 <a:latin typeface="Consolas"/>
               </a:rPr>
-              <a:t># support for either keyword.</a:t>
+              <a:t>    system_instruction=SYSTEM_PROMPT,</a:t>
             </a:r>
           </a:p>
           <a:p>
@@ -6437,7 +6181,7 @@
                 </a:solidFill>
                 <a:latin typeface="Consolas"/>
               </a:rPr>
-              <a:t/>
+              <a:t>    input=_input_blocks(document),</a:t>
             </a:r>
           </a:p>
           <a:p>
@@ -6455,11 +6199,11 @@
             <a:r>
               <a:rPr sz="1050" b="0" i="0">
                 <a:solidFill>
-                  <a:srgbClr val="F2C97D"/>
+                  <a:srgbClr val="E4EDF2"/>
                 </a:solidFill>
                 <a:latin typeface="Consolas"/>
               </a:rPr>
-              <a:t>def response_schema() -&gt; dict:</a:t>
+              <a:t>    response_format={</a:t>
             </a:r>
           </a:p>
           <a:p>
@@ -6477,11 +6221,11 @@
             <a:r>
               <a:rPr sz="1050" b="0" i="0">
                 <a:solidFill>
-                  <a:srgbClr val="E4EDF2"/>
+                  <a:srgbClr val="B8E0A0"/>
                 </a:solidFill>
                 <a:latin typeface="Consolas"/>
               </a:rPr>
-              <a:t>    schema = ClinicalExtraction.model_json_schema()</a:t>
+              <a:t>        "type": "text",</a:t>
             </a:r>
           </a:p>
           <a:p>
@@ -6499,11 +6243,11 @@
             <a:r>
               <a:rPr sz="1050" b="0" i="0">
                 <a:solidFill>
-                  <a:srgbClr val="E4EDF2"/>
+                  <a:srgbClr val="B8E0A0"/>
                 </a:solidFill>
                 <a:latin typeface="Consolas"/>
               </a:rPr>
-              <a:t>    defs = schema.pop("$defs", {})</a:t>
+              <a:t>        "mime_type": "application/json",</a:t>
             </a:r>
           </a:p>
           <a:p>
@@ -6521,11 +6265,11 @@
             <a:r>
               <a:rPr sz="1050" b="0" i="0">
                 <a:solidFill>
-                  <a:srgbClr val="E4EDF2"/>
+                  <a:srgbClr val="B8E0A0"/>
                 </a:solidFill>
                 <a:latin typeface="Consolas"/>
               </a:rPr>
-              <a:t>    return _inline_refs(schema, defs)</a:t>
+              <a:t>        "schema": response_schema(),</a:t>
             </a:r>
           </a:p>
           <a:p>
@@ -6547,7 +6291,7 @@
                 </a:solidFill>
                 <a:latin typeface="Consolas"/>
               </a:rPr>
-              <a:t/>
+              <a:t>    },</a:t>
             </a:r>
           </a:p>
           <a:p>
@@ -6569,7 +6313,7 @@
                 </a:solidFill>
                 <a:latin typeface="Consolas"/>
               </a:rPr>
-              <a:t># Inlined before the request goes out, rather</a:t>
+              <a:t>    store=False,  # nothing retained</a:t>
             </a:r>
           </a:p>
           <a:p>
@@ -6587,25 +6331,25 @@
             <a:r>
               <a:rPr sz="1050" b="0" i="0">
                 <a:solidFill>
-                  <a:srgbClr val="6B8794"/>
+                  <a:srgbClr val="E4EDF2"/>
                 </a:solidFill>
                 <a:latin typeface="Consolas"/>
               </a:rPr>
-              <a:t># than relying on undocumented behaviour.</a:t>
-            </a:r>
-          </a:p>
-        </p:txBody>
-      </p:sp>
-      <p:sp>
-        <p:nvSpPr>
-          <p:cNvPr id="14" name="TextBox 13"/>
+              <a:t>)</a:t>
+            </a:r>
+          </a:p>
+        </p:txBody>
+      </p:sp>
+      <p:sp>
+        <p:nvSpPr>
+          <p:cNvPr id="13" name="TextBox 12"/>
           <p:cNvSpPr txBox="1"/>
           <p:nvPr/>
         </p:nvSpPr>
         <p:spPr>
           <a:xfrm>
-            <a:off x="6355080" y="4169663"/>
-            <a:ext cx="5276088" cy="603504"/>
+            <a:off x="6601968" y="4327619"/>
+            <a:ext cx="5029200" cy="548640"/>
           </a:xfrm>
           <a:prstGeom prst="rect">
             <a:avLst/>
@@ -6636,14 +6380,14 @@
                 </a:solidFill>
                 <a:latin typeface="Calibri"/>
               </a:rPr>
-              <a:t>Found by reading the SDK's own request types rather than trusting the docs page — which also revealed the API accepts TIFF, the format scanned clinical faxes actually arrive in.</a:t>
-            </a:r>
-          </a:p>
-        </p:txBody>
-      </p:sp>
-      <p:sp>
-        <p:nvSpPr>
-          <p:cNvPr id="15" name="TextBox 14"/>
+              <a:t>No JSON parsing, no repair loop, no prose-to-struct step that can drift. response_schema() inlines the $defs/$ref Gemini does not document.</a:t>
+            </a:r>
+          </a:p>
+        </p:txBody>
+      </p:sp>
+      <p:sp>
+        <p:nvSpPr>
+          <p:cNvPr id="14" name="TextBox 13"/>
           <p:cNvSpPr txBox="1"/>
           <p:nvPr/>
         </p:nvSpPr>
@@ -6678,14 +6422,14 @@
                 </a:solidFill>
                 <a:latin typeface="Calibri"/>
               </a:rPr>
-              <a:t>MEASURED ON THE FIVE BUNDLED SAMPLES</a:t>
-            </a:r>
-          </a:p>
-        </p:txBody>
-      </p:sp>
-      <p:sp>
-        <p:nvSpPr>
-          <p:cNvPr id="16" name="Rounded Rectangle 15"/>
+              <a:t>MEASURED ON THE SIX BUNDLED SAMPLES</a:t>
+            </a:r>
+          </a:p>
+        </p:txBody>
+      </p:sp>
+      <p:sp>
+        <p:nvSpPr>
+          <p:cNvPr id="15" name="Rounded Rectangle 14"/>
           <p:cNvSpPr/>
           <p:nvPr/>
         </p:nvSpPr>
@@ -6733,7 +6477,7 @@
       </p:sp>
       <p:sp>
         <p:nvSpPr>
-          <p:cNvPr id="17" name="TextBox 16"/>
+          <p:cNvPr id="16" name="TextBox 15"/>
           <p:cNvSpPr txBox="1"/>
           <p:nvPr/>
         </p:nvSpPr>
@@ -6798,7 +6542,7 @@
       </p:sp>
       <p:sp>
         <p:nvSpPr>
-          <p:cNvPr id="18" name="Rounded Rectangle 17"/>
+          <p:cNvPr id="17" name="Rounded Rectangle 16"/>
           <p:cNvSpPr/>
           <p:nvPr/>
         </p:nvSpPr>
@@ -6846,7 +6590,7 @@
       </p:sp>
       <p:sp>
         <p:nvSpPr>
-          <p:cNvPr id="19" name="TextBox 18"/>
+          <p:cNvPr id="18" name="TextBox 17"/>
           <p:cNvSpPr txBox="1"/>
           <p:nvPr/>
         </p:nvSpPr>
@@ -6911,7 +6655,7 @@
       </p:sp>
       <p:sp>
         <p:nvSpPr>
-          <p:cNvPr id="20" name="Rounded Rectangle 19"/>
+          <p:cNvPr id="19" name="Rounded Rectangle 18"/>
           <p:cNvSpPr/>
           <p:nvPr/>
         </p:nvSpPr>
@@ -6959,7 +6703,7 @@
       </p:sp>
       <p:sp>
         <p:nvSpPr>
-          <p:cNvPr id="21" name="TextBox 20"/>
+          <p:cNvPr id="20" name="TextBox 19"/>
           <p:cNvSpPr txBox="1"/>
           <p:nvPr/>
         </p:nvSpPr>
@@ -7024,7 +6768,7 @@
       </p:sp>
       <p:sp>
         <p:nvSpPr>
-          <p:cNvPr id="22" name="Rounded Rectangle 21"/>
+          <p:cNvPr id="21" name="Rounded Rectangle 20"/>
           <p:cNvSpPr/>
           <p:nvPr/>
         </p:nvSpPr>
@@ -7072,7 +6816,7 @@
       </p:sp>
       <p:sp>
         <p:nvSpPr>
-          <p:cNvPr id="23" name="TextBox 22"/>
+          <p:cNvPr id="22" name="TextBox 21"/>
           <p:cNvSpPr txBox="1"/>
           <p:nvPr/>
         </p:nvSpPr>
@@ -7137,7 +6881,7 @@
       </p:sp>
       <p:sp>
         <p:nvSpPr>
-          <p:cNvPr id="24" name="Rounded Rectangle 23"/>
+          <p:cNvPr id="23" name="Rounded Rectangle 22"/>
           <p:cNvSpPr/>
           <p:nvPr/>
         </p:nvSpPr>
@@ -7185,7 +6929,7 @@
       </p:sp>
       <p:sp>
         <p:nvSpPr>
-          <p:cNvPr id="25" name="TextBox 24"/>
+          <p:cNvPr id="24" name="TextBox 23"/>
           <p:cNvSpPr txBox="1"/>
           <p:nvPr/>
         </p:nvSpPr>
@@ -7250,7 +6994,7 @@
       </p:sp>
       <p:sp>
         <p:nvSpPr>
-          <p:cNvPr id="26" name="TextBox 25"/>
+          <p:cNvPr id="25" name="TextBox 24"/>
           <p:cNvSpPr txBox="1"/>
           <p:nvPr/>
         </p:nvSpPr>

</xml_diff>